<commit_message>
Adiciona link do app online no README e na apresentacao
</commit_message>
<xml_diff>
--- a/Apresentacao_NLP.pptx
+++ b/Apresentacao_NLP.pptx
@@ -654,7 +654,7 @@
           <a:lstStyle/>
           <a:p>
             <a:r>
-              <a:t>Aqui você abre o app ao vivo (ou mostra um print). Faça UMA busca na frente da turma — é o momento de maior impacto. (~1,5 min)</a:t>
+              <a:t>Aqui você abre o app ao vivo (ou mostra um print). Faça UMA busca na frente da turma — é o momento de maior impacto. O link está no slide. (~1,5 min)</a:t>
             </a:r>
           </a:p>
         </p:txBody>
@@ -4974,6 +4974,69 @@
                 <a:latin typeface="Segoe UI"/>
               </a:rPr>
               <a:t>•  Publicado gratuitamente na nuvem (Streamlit Community Cloud).</a:t>
+            </a:r>
+          </a:p>
+        </p:txBody>
+      </p:sp>
+      <p:sp>
+        <p:nvSpPr>
+          <p:cNvPr id="6" name="Rectangle 5"/>
+          <p:cNvSpPr/>
+          <p:nvPr/>
+        </p:nvSpPr>
+        <p:spPr>
+          <a:xfrm>
+            <a:off x="822960" y="5074920"/>
+            <a:ext cx="10515600" cy="868680"/>
+          </a:xfrm>
+          <a:prstGeom prst="rect">
+            <a:avLst/>
+          </a:prstGeom>
+          <a:solidFill>
+            <a:srgbClr val="6C5CE7"/>
+          </a:solidFill>
+          <a:ln>
+            <a:noFill/>
+          </a:ln>
+          <a:effectLst/>
+        </p:spPr>
+        <p:style>
+          <a:lnRef idx="1">
+            <a:schemeClr val="accent1"/>
+          </a:lnRef>
+          <a:fillRef idx="3">
+            <a:schemeClr val="accent1"/>
+          </a:fillRef>
+          <a:effectRef idx="2">
+            <a:schemeClr val="accent1"/>
+          </a:effectRef>
+          <a:fontRef idx="minor">
+            <a:schemeClr val="lt1"/>
+          </a:fontRef>
+        </p:style>
+        <p:txBody>
+          <a:bodyPr rtlCol="0" anchor="ctr" wrap="square"/>
+          <a:lstStyle/>
+          <a:p>
+            <a:pPr algn="ctr"/>
+            <a:r>
+              <a:rPr sz="1800" b="1">
+                <a:solidFill>
+                  <a:srgbClr val="FFFFFF"/>
+                </a:solidFill>
+                <a:latin typeface="Segoe UI"/>
+              </a:rPr>
+              <a:t>🔗  Acesse o app:  </a:t>
+            </a:r>
+            <a:r>
+              <a:rPr sz="1800">
+                <a:solidFill>
+                  <a:srgbClr val="EAE7FF"/>
+                </a:solidFill>
+                <a:latin typeface="Segoe UI"/>
+                <a:hlinkClick r:id="rId3"/>
+              </a:rPr>
+              <a:t>https://trabalho-nlp-lw2nakkbxysdjuxkaipr3x.streamlit.app/</a:t>
             </a:r>
           </a:p>
         </p:txBody>

</xml_diff>

<commit_message>
Adiciona slide de potencial de aplicacao (memoria semantica da empresa)
</commit_message>
<xml_diff>
--- a/Apresentacao_NLP.pptx
+++ b/Apresentacao_NLP.pptx
@@ -18,6 +18,7 @@
     <p:sldId id="266" r:id="rId18"/>
     <p:sldId id="267" r:id="rId19"/>
     <p:sldId id="268" r:id="rId20"/>
+    <p:sldId id="269" r:id="rId21"/>
   </p:sldIdLst>
   <p:sldSz cx="12191695" cy="6858000" type="screen4x3"/>
   <p:notesSz cx="6858000" cy="9144000"/>
@@ -724,7 +725,7 @@
           <a:lstStyle/>
           <a:p>
             <a:r>
-              <a:t>Feche conectando com o mundo real: é a mesma ideia por trás do ChatGPT com busca, do Google semântico, etc. Reforce que o objetivo foi cumprido. (~1 min)</a:t>
+              <a:t>Apresente como a VISÃO de futuro do trabalho. A mesma técnica vira um 'banco de memórias' da empresa: em vez de avaliações, indexe documentos, pesquisas e atas. Aí qualquer pessoa 'lembra' de algo buscando por significado — ex.: puxar um dado de uma pesquisa antiga para um projeto atual. É a base do que o mercado chama de RAG (busca semântica + IA). (~1 min)</a:t>
             </a:r>
           </a:p>
         </p:txBody>
@@ -750,6 +751,76 @@
 </file>
 
 <file path=ppt/notesSlides/notesSlide13.xml><?xml version="1.0" encoding="utf-8"?>
+<p:notes xmlns:a="http://schemas.openxmlformats.org/drawingml/2006/main" xmlns:p="http://schemas.openxmlformats.org/presentationml/2006/main" xmlns:r="http://schemas.openxmlformats.org/officeDocument/2006/relationships">
+  <p:cSld>
+    <p:spTree>
+      <p:nvGrpSpPr>
+        <p:cNvPr id="1" name=""/>
+        <p:cNvGrpSpPr/>
+        <p:nvPr/>
+      </p:nvGrpSpPr>
+      <p:grpSpPr>
+        <a:xfrm>
+          <a:off x="0" y="0"/>
+          <a:ext cx="0" cy="0"/>
+          <a:chOff x="0" y="0"/>
+          <a:chExt cx="0" cy="0"/>
+        </a:xfrm>
+      </p:grpSpPr>
+      <p:sp>
+        <p:nvSpPr>
+          <p:cNvPr id="2" name="Slide Image Placeholder 1"/>
+          <p:cNvSpPr>
+            <a:spLocks noGrp="1"/>
+          </p:cNvSpPr>
+          <p:nvPr>
+            <p:ph type="sldImg" idx="2"/>
+          </p:nvPr>
+        </p:nvSpPr>
+        <p:spPr/>
+      </p:sp>
+      <p:sp>
+        <p:nvSpPr>
+          <p:cNvPr id="3" name="Notes Placeholder 2"/>
+          <p:cNvSpPr>
+            <a:spLocks noGrp="1"/>
+          </p:cNvSpPr>
+          <p:nvPr>
+            <p:ph type="body" idx="3" sz="quarter"/>
+          </p:nvPr>
+        </p:nvSpPr>
+        <p:spPr/>
+        <p:txBody>
+          <a:bodyPr/>
+          <a:lstStyle/>
+          <a:p>
+            <a:r>
+              <a:t>Feche conectando com o mundo real: é a mesma ideia por trás do ChatGPT com busca, do Google semântico, etc. Reforce que o objetivo foi cumprido. (~1 min)</a:t>
+            </a:r>
+          </a:p>
+        </p:txBody>
+      </p:sp>
+      <p:sp>
+        <p:nvSpPr>
+          <p:cNvPr id="4" name="Slide Number Placeholder 3"/>
+          <p:cNvSpPr>
+            <a:spLocks noGrp="1"/>
+          </p:cNvSpPr>
+          <p:nvPr>
+            <p:ph type="sldNum" idx="5" sz="quarter"/>
+          </p:nvPr>
+        </p:nvSpPr>
+        <p:spPr/>
+      </p:sp>
+    </p:spTree>
+  </p:cSld>
+  <p:clrMapOvr>
+    <a:masterClrMapping/>
+  </p:clrMapOvr>
+</p:notes>
+</file>
+
+<file path=ppt/notesSlides/notesSlide14.xml><?xml version="1.0" encoding="utf-8"?>
 <p:notes xmlns:a="http://schemas.openxmlformats.org/drawingml/2006/main" xmlns:p="http://schemas.openxmlformats.org/presentationml/2006/main" xmlns:r="http://schemas.openxmlformats.org/officeDocument/2006/relationships">
   <p:cSld>
     <p:spTree>
@@ -5189,7 +5260,7 @@
                 </a:solidFill>
                 <a:latin typeface="Segoe UI"/>
               </a:rPr>
-              <a:t>Conclusão</a:t>
+              <a:t>Potencial: a memória da empresa</a:t>
             </a:r>
           </a:p>
         </p:txBody>
@@ -5228,7 +5299,7 @@
                 </a:solidFill>
                 <a:latin typeface="Segoe UI"/>
               </a:rPr>
-              <a:t>•  Demonstramos uma busca que entende o SIGNIFICADO do texto.</a:t>
+              <a:t>•  E se a empresa pudesse "lembrar" de tudo o que já produziu?</a:t>
             </a:r>
           </a:p>
           <a:p>
@@ -5244,7 +5315,7 @@
                 </a:solidFill>
                 <a:latin typeface="Segoe UI"/>
               </a:rPr>
-              <a:t>•  Embeddings + similaridade do cosseno recuperam informação relevante.</a:t>
+              <a:t>•  Alimente o sistema com qualquer texto: documentos, projetos, pesquisas científicas, atas e conversas com investidores.</a:t>
             </a:r>
           </a:p>
           <a:p>
@@ -5260,7 +5331,7 @@
                 </a:solidFill>
                 <a:latin typeface="Segoe UI"/>
               </a:rPr>
-              <a:t>•  É a base de tecnologias atuais: buscadores semânticos, assistentes de IA e bancos de dados vetoriais (RAG).</a:t>
+              <a:t>•  Tudo vira vetor e fica recuperável por significado — uma verdadeira memória semântica da organização.</a:t>
             </a:r>
           </a:p>
           <a:p>
@@ -5276,7 +5347,55 @@
                 </a:solidFill>
                 <a:latin typeface="Segoe UI"/>
               </a:rPr>
-              <a:t>•  NLP ajuda a interpretar e recuperar conhecimento em grandes volumes de texto.</a:t>
+              <a:t>•  Exemplos de uso:</a:t>
+            </a:r>
+          </a:p>
+          <a:p>
+            <a:pPr algn="l">
+              <a:spcAft>
+                <a:spcPts val="1000"/>
+              </a:spcAft>
+            </a:pPr>
+            <a:r>
+              <a:rPr sz="2000" b="0">
+                <a:solidFill>
+                  <a:srgbClr val="475569"/>
+                </a:solidFill>
+                <a:latin typeface="Segoe UI"/>
+              </a:rPr>
+              <a:t>•  Resgatar um achado de uma pesquisa científica interna para um projeto em andamento.</a:t>
+            </a:r>
+          </a:p>
+          <a:p>
+            <a:pPr algn="l">
+              <a:spcAft>
+                <a:spcPts val="1000"/>
+              </a:spcAft>
+            </a:pPr>
+            <a:r>
+              <a:rPr sz="2000" b="0">
+                <a:solidFill>
+                  <a:srgbClr val="475569"/>
+                </a:solidFill>
+                <a:latin typeface="Segoe UI"/>
+              </a:rPr>
+              <a:t>•  Relembrar o que foi tratado em conversas com investidores.</a:t>
+            </a:r>
+          </a:p>
+          <a:p>
+            <a:pPr algn="l">
+              <a:spcAft>
+                <a:spcPts val="1000"/>
+              </a:spcAft>
+            </a:pPr>
+            <a:r>
+              <a:rPr sz="2000" b="0">
+                <a:solidFill>
+                  <a:srgbClr val="475569"/>
+                </a:solidFill>
+                <a:latin typeface="Segoe UI"/>
+              </a:rPr>
+              <a:t>•  Encontrar projetos antigos parecidos com o desafio de agora.</a:t>
             </a:r>
           </a:p>
         </p:txBody>
@@ -5290,6 +5409,246 @@
 </file>
 
 <file path=ppt/slides/slide13.xml><?xml version="1.0" encoding="utf-8"?>
+<p:sld xmlns:a="http://schemas.openxmlformats.org/drawingml/2006/main" xmlns:p="http://schemas.openxmlformats.org/presentationml/2006/main" xmlns:r="http://schemas.openxmlformats.org/officeDocument/2006/relationships">
+  <p:cSld>
+    <p:bg>
+      <p:bgPr>
+        <a:solidFill>
+          <a:srgbClr val="FFFFFF"/>
+        </a:solidFill>
+        <a:effectLst/>
+      </p:bgPr>
+    </p:bg>
+    <p:spTree>
+      <p:nvGrpSpPr>
+        <p:cNvPr id="1" name=""/>
+        <p:cNvGrpSpPr/>
+        <p:nvPr/>
+      </p:nvGrpSpPr>
+      <p:grpSpPr/>
+      <p:sp>
+        <p:nvSpPr>
+          <p:cNvPr id="2" name="Rectangle 1"/>
+          <p:cNvSpPr/>
+          <p:nvPr/>
+        </p:nvSpPr>
+        <p:spPr>
+          <a:xfrm>
+            <a:off x="0" y="0"/>
+            <a:ext cx="12191695" cy="256032"/>
+          </a:xfrm>
+          <a:prstGeom prst="rect">
+            <a:avLst/>
+          </a:prstGeom>
+          <a:solidFill>
+            <a:srgbClr val="6C5CE7"/>
+          </a:solidFill>
+          <a:ln>
+            <a:noFill/>
+          </a:ln>
+          <a:effectLst/>
+        </p:spPr>
+        <p:style>
+          <a:lnRef idx="1">
+            <a:schemeClr val="accent1"/>
+          </a:lnRef>
+          <a:fillRef idx="3">
+            <a:schemeClr val="accent1"/>
+          </a:fillRef>
+          <a:effectRef idx="2">
+            <a:schemeClr val="accent1"/>
+          </a:effectRef>
+          <a:fontRef idx="minor">
+            <a:schemeClr val="lt1"/>
+          </a:fontRef>
+        </p:style>
+        <p:txBody>
+          <a:bodyPr rtlCol="0" anchor="ctr"/>
+          <a:lstStyle/>
+          <a:p>
+            <a:pPr algn="ctr"/>
+          </a:p>
+        </p:txBody>
+      </p:sp>
+      <p:sp>
+        <p:nvSpPr>
+          <p:cNvPr id="3" name="Rectangle 2"/>
+          <p:cNvSpPr/>
+          <p:nvPr/>
+        </p:nvSpPr>
+        <p:spPr>
+          <a:xfrm>
+            <a:off x="0" y="256032"/>
+            <a:ext cx="2194560" cy="54864"/>
+          </a:xfrm>
+          <a:prstGeom prst="rect">
+            <a:avLst/>
+          </a:prstGeom>
+          <a:solidFill>
+            <a:srgbClr val="00C2C7"/>
+          </a:solidFill>
+          <a:ln>
+            <a:noFill/>
+          </a:ln>
+          <a:effectLst/>
+        </p:spPr>
+        <p:style>
+          <a:lnRef idx="1">
+            <a:schemeClr val="accent1"/>
+          </a:lnRef>
+          <a:fillRef idx="3">
+            <a:schemeClr val="accent1"/>
+          </a:fillRef>
+          <a:effectRef idx="2">
+            <a:schemeClr val="accent1"/>
+          </a:effectRef>
+          <a:fontRef idx="minor">
+            <a:schemeClr val="lt1"/>
+          </a:fontRef>
+        </p:style>
+        <p:txBody>
+          <a:bodyPr rtlCol="0" anchor="ctr"/>
+          <a:lstStyle/>
+          <a:p>
+            <a:pPr algn="ctr"/>
+          </a:p>
+        </p:txBody>
+      </p:sp>
+      <p:sp>
+        <p:nvSpPr>
+          <p:cNvPr id="4" name="TextBox 3"/>
+          <p:cNvSpPr txBox="1"/>
+          <p:nvPr/>
+        </p:nvSpPr>
+        <p:spPr>
+          <a:xfrm>
+            <a:off x="640080" y="502920"/>
+            <a:ext cx="10972800" cy="914400"/>
+          </a:xfrm>
+          <a:prstGeom prst="rect">
+            <a:avLst/>
+          </a:prstGeom>
+          <a:noFill/>
+        </p:spPr>
+        <p:txBody>
+          <a:bodyPr wrap="square" anchor="t">
+            <a:spAutoFit/>
+          </a:bodyPr>
+          <a:lstStyle/>
+          <a:p>
+            <a:pPr algn="l">
+              <a:spcAft>
+                <a:spcPts val="1000"/>
+              </a:spcAft>
+            </a:pPr>
+            <a:r>
+              <a:rPr sz="3200" b="1">
+                <a:solidFill>
+                  <a:srgbClr val="1E1B2E"/>
+                </a:solidFill>
+                <a:latin typeface="Segoe UI"/>
+              </a:rPr>
+              <a:t>Conclusão</a:t>
+            </a:r>
+          </a:p>
+        </p:txBody>
+      </p:sp>
+      <p:sp>
+        <p:nvSpPr>
+          <p:cNvPr id="5" name="TextBox 4"/>
+          <p:cNvSpPr txBox="1"/>
+          <p:nvPr/>
+        </p:nvSpPr>
+        <p:spPr>
+          <a:xfrm>
+            <a:off x="822960" y="1645920"/>
+            <a:ext cx="10515600" cy="4754880"/>
+          </a:xfrm>
+          <a:prstGeom prst="rect">
+            <a:avLst/>
+          </a:prstGeom>
+          <a:noFill/>
+        </p:spPr>
+        <p:txBody>
+          <a:bodyPr wrap="square" anchor="t">
+            <a:spAutoFit/>
+          </a:bodyPr>
+          <a:lstStyle/>
+          <a:p>
+            <a:pPr algn="l">
+              <a:spcAft>
+                <a:spcPts val="1000"/>
+              </a:spcAft>
+            </a:pPr>
+            <a:r>
+              <a:rPr sz="2200" b="1">
+                <a:solidFill>
+                  <a:srgbClr val="1E1B2E"/>
+                </a:solidFill>
+                <a:latin typeface="Segoe UI"/>
+              </a:rPr>
+              <a:t>•  Demonstramos uma busca que entende o SIGNIFICADO do texto.</a:t>
+            </a:r>
+          </a:p>
+          <a:p>
+            <a:pPr algn="l">
+              <a:spcAft>
+                <a:spcPts val="1000"/>
+              </a:spcAft>
+            </a:pPr>
+            <a:r>
+              <a:rPr sz="2000" b="0">
+                <a:solidFill>
+                  <a:srgbClr val="475569"/>
+                </a:solidFill>
+                <a:latin typeface="Segoe UI"/>
+              </a:rPr>
+              <a:t>•  Embeddings + similaridade do cosseno recuperam informação relevante.</a:t>
+            </a:r>
+          </a:p>
+          <a:p>
+            <a:pPr algn="l">
+              <a:spcAft>
+                <a:spcPts val="1000"/>
+              </a:spcAft>
+            </a:pPr>
+            <a:r>
+              <a:rPr sz="2000" b="0">
+                <a:solidFill>
+                  <a:srgbClr val="475569"/>
+                </a:solidFill>
+                <a:latin typeface="Segoe UI"/>
+              </a:rPr>
+              <a:t>•  É a base de tecnologias atuais: buscadores semânticos, assistentes de IA e bancos de dados vetoriais (RAG).</a:t>
+            </a:r>
+          </a:p>
+          <a:p>
+            <a:pPr algn="l">
+              <a:spcAft>
+                <a:spcPts val="1000"/>
+              </a:spcAft>
+            </a:pPr>
+            <a:r>
+              <a:rPr sz="2000" b="1">
+                <a:solidFill>
+                  <a:srgbClr val="1E1B2E"/>
+                </a:solidFill>
+                <a:latin typeface="Segoe UI"/>
+              </a:rPr>
+              <a:t>•  NLP ajuda a interpretar e recuperar conhecimento em grandes volumes de texto.</a:t>
+            </a:r>
+          </a:p>
+        </p:txBody>
+      </p:sp>
+    </p:spTree>
+  </p:cSld>
+  <p:clrMapOvr>
+    <a:masterClrMapping/>
+  </p:clrMapOvr>
+</p:sld>
+</file>
+
+<file path=ppt/slides/slide14.xml><?xml version="1.0" encoding="utf-8"?>
 <p:sld xmlns:a="http://schemas.openxmlformats.org/drawingml/2006/main" xmlns:p="http://schemas.openxmlformats.org/presentationml/2006/main" xmlns:r="http://schemas.openxmlformats.org/officeDocument/2006/relationships">
   <p:cSld>
     <p:bg>

</xml_diff>